<commit_message>
Add Karnataka data, tariff engine, and scenario simulator
</commit_message>
<xml_diff>
--- a/submission-deck/GridSense_AI_Prototype_Submission.pptx
+++ b/submission-deck/GridSense_AI_Prototype_Submission.pptx
@@ -3294,7 +3294,7 @@
                   <a:srgbClr val="475569"/>
                 </a:solidFill>
               </a:rPr>
-              <a:t>Model feedback loop from inspection outcomes</a:t>
+              <a:t>Live BESCOM tariff and subsidy configuration management</a:t>
             </a:r>
             <a:endParaRPr lang="en-US" sz="1200" dirty="0"/>
           </a:p>
@@ -3334,6 +3334,69 @@
         <p:spPr>
           <a:xfrm>
             <a:off x="1060704" y="6099048"/>
+            <a:ext cx="9875520" cy="329184"/>
+          </a:xfrm>
+          <a:prstGeom prst="rect">
+            <a:avLst/>
+          </a:prstGeom>
+          <a:noFill/>
+          <a:ln/>
+        </p:spPr>
+        <p:txBody>
+          <a:bodyPr wrap="square" lIns="0" tIns="0" rIns="0" bIns="0" rtlCol="0" anchor="ctr">
+            <a:normAutofit/>
+          </a:bodyPr>
+          <a:lstStyle/>
+          <a:p>
+            <a:pPr indent="0" marL="0">
+              <a:buNone/>
+            </a:pPr>
+            <a:r>
+              <a:rPr lang="en-US" sz="1200" dirty="0">
+                <a:solidFill>
+                  <a:srgbClr val="475569"/>
+                </a:solidFill>
+              </a:rPr>
+              <a:t>Model feedback loop from inspection outcomes</a:t>
+            </a:r>
+            <a:endParaRPr lang="en-US" sz="1200" dirty="0"/>
+          </a:p>
+        </p:txBody>
+      </p:sp>
+      <p:sp>
+        <p:nvSpPr>
+          <p:cNvPr id="33" name="Shape 31"/>
+          <p:cNvSpPr/>
+          <p:nvPr/>
+        </p:nvSpPr>
+        <p:spPr>
+          <a:xfrm>
+            <a:off x="841248" y="6656832"/>
+            <a:ext cx="109728" cy="109728"/>
+          </a:xfrm>
+          <a:prstGeom prst="ellipse">
+            <a:avLst/>
+          </a:prstGeom>
+          <a:solidFill>
+            <a:srgbClr val="F97316"/>
+          </a:solidFill>
+          <a:ln w="12700">
+            <a:solidFill>
+              <a:srgbClr val="F97316"/>
+            </a:solidFill>
+            <a:prstDash val="solid"/>
+          </a:ln>
+        </p:spPr>
+      </p:sp>
+      <p:sp>
+        <p:nvSpPr>
+          <p:cNvPr id="34" name="Text 32"/>
+          <p:cNvSpPr/>
+          <p:nvPr/>
+        </p:nvSpPr>
+        <p:spPr>
+          <a:xfrm>
+            <a:off x="1060704" y="6583680"/>
             <a:ext cx="9875520" cy="329184"/>
           </a:xfrm>
           <a:prstGeom prst="rect">
@@ -6111,7 +6174,7 @@
                   <a:srgbClr val="475569"/>
                 </a:solidFill>
               </a:rPr>
-              <a:t>Rank inspection cases by confidence, loss impact, and urgency.</a:t>
+              <a:t>Rank inspection cases by confidence, loss impact, urgency, and tariff savings.</a:t>
             </a:r>
             <a:endParaRPr lang="en-US" sz="950" dirty="0"/>
           </a:p>
@@ -8207,7 +8270,7 @@
                   <a:srgbClr val="0F172A"/>
                 </a:solidFill>
               </a:rPr>
-              <a:t>Bengaluru Zone Map</a:t>
+              <a:t>Karnataka Data Layer</a:t>
             </a:r>
             <a:endParaRPr lang="en-US" sz="1200" dirty="0"/>
           </a:p>
@@ -8245,7 +8308,7 @@
                   <a:srgbClr val="475569"/>
                 </a:solidFill>
               </a:rPr>
-              <a:t>Peenya, Whitefield, KR Puram, Yelahanka, and Electronic City style zones.</a:t>
+              <a:t>CSV-backed feeder profile with irrigation, solar, and evening domestic load patterns.</a:t>
             </a:r>
             <a:endParaRPr lang="en-US" sz="950" dirty="0"/>
           </a:p>
@@ -8340,7 +8403,7 @@
                   <a:srgbClr val="0F172A"/>
                 </a:solidFill>
               </a:rPr>
-              <a:t>Revenue Engine</a:t>
+              <a:t>Bengaluru Zone Map</a:t>
             </a:r>
             <a:endParaRPr lang="en-US" sz="1200" dirty="0"/>
           </a:p>
@@ -8378,7 +8441,7 @@
                   <a:srgbClr val="475569"/>
                 </a:solidFill>
               </a:rPr>
-              <a:t>Estimated loss, recovery potential, and zone loss chart.</a:t>
+              <a:t>Peenya, Whitefield, KR Puram, Yelahanka, and Electronic City style zones.</a:t>
             </a:r>
             <a:endParaRPr lang="en-US" sz="950" dirty="0"/>
           </a:p>
@@ -8473,7 +8536,7 @@
                   <a:srgbClr val="0F172A"/>
                 </a:solidFill>
               </a:rPr>
-              <a:t>Inspection Queue</a:t>
+              <a:t>Tariff + Carbon Engine</a:t>
             </a:r>
             <a:endParaRPr lang="en-US" sz="1200" dirty="0"/>
           </a:p>
@@ -8511,7 +8574,7 @@
                   <a:srgbClr val="475569"/>
                 </a:solidFill>
               </a:rPr>
-              <a:t>Approve, reject, or escalate Bengaluru-area cases.</a:t>
+              <a:t>Monthly savings and CO2 impact from BESCOM-style optimization scenarios.</a:t>
             </a:r>
             <a:endParaRPr lang="en-US" sz="950" dirty="0"/>
           </a:p>
@@ -8606,7 +8669,7 @@
                   <a:srgbClr val="0F172A"/>
                 </a:solidFill>
               </a:rPr>
-              <a:t>Explainability</a:t>
+              <a:t>Inspection Queue</a:t>
             </a:r>
             <a:endParaRPr lang="en-US" sz="1200" dirty="0"/>
           </a:p>
@@ -8644,7 +8707,140 @@
                   <a:srgbClr val="475569"/>
                 </a:solidFill>
               </a:rPr>
-              <a:t>Reason, formula, and audit timeline for every alert.</a:t>
+              <a:t>Approve, reject, or escalate Bengaluru-area cases.</a:t>
+            </a:r>
+            <a:endParaRPr lang="en-US" sz="950" dirty="0"/>
+          </a:p>
+        </p:txBody>
+      </p:sp>
+      <p:sp>
+        <p:nvSpPr>
+          <p:cNvPr id="34" name="Shape 32"/>
+          <p:cNvSpPr/>
+          <p:nvPr/>
+        </p:nvSpPr>
+        <p:spPr>
+          <a:xfrm>
+            <a:off x="658368" y="4928616"/>
+            <a:ext cx="3337560" cy="1115568"/>
+          </a:xfrm>
+          <a:prstGeom prst="roundRect">
+            <a:avLst>
+              <a:gd name="adj" fmla="val 6557"/>
+            </a:avLst>
+          </a:prstGeom>
+          <a:solidFill>
+            <a:srgbClr val="FFFFFF"/>
+          </a:solidFill>
+          <a:ln w="12700">
+            <a:solidFill>
+              <a:srgbClr val="D9E2F2"/>
+            </a:solidFill>
+            <a:prstDash val="solid"/>
+          </a:ln>
+          <a:effectLst>
+            <a:outerShdw sx="100000" sy="100000" kx="0" ky="0" algn="bl" rotWithShape="0" blurRad="12700" dist="50800" dir="2700000">
+              <a:srgbClr val="DDE6F4">
+                <a:alpha val="35000"/>
+              </a:srgbClr>
+            </a:outerShdw>
+          </a:effectLst>
+        </p:spPr>
+      </p:sp>
+      <p:sp>
+        <p:nvSpPr>
+          <p:cNvPr id="35" name="Shape 33"/>
+          <p:cNvSpPr/>
+          <p:nvPr/>
+        </p:nvSpPr>
+        <p:spPr>
+          <a:xfrm>
+            <a:off x="658368" y="4928616"/>
+            <a:ext cx="109728" cy="1115568"/>
+          </a:xfrm>
+          <a:prstGeom prst="rect">
+            <a:avLst/>
+          </a:prstGeom>
+          <a:solidFill>
+            <a:srgbClr val="2563EB"/>
+          </a:solidFill>
+          <a:ln w="12700">
+            <a:solidFill>
+              <a:srgbClr val="2563EB"/>
+            </a:solidFill>
+            <a:prstDash val="solid"/>
+          </a:ln>
+        </p:spPr>
+      </p:sp>
+      <p:sp>
+        <p:nvSpPr>
+          <p:cNvPr id="36" name="Text 34"/>
+          <p:cNvSpPr/>
+          <p:nvPr/>
+        </p:nvSpPr>
+        <p:spPr>
+          <a:xfrm>
+            <a:off x="914400" y="5129784"/>
+            <a:ext cx="2935224" cy="219456"/>
+          </a:xfrm>
+          <a:prstGeom prst="rect">
+            <a:avLst/>
+          </a:prstGeom>
+          <a:noFill/>
+          <a:ln/>
+        </p:spPr>
+        <p:txBody>
+          <a:bodyPr wrap="square" lIns="0" tIns="0" rIns="0" bIns="0" rtlCol="0" anchor="ctr"/>
+          <a:lstStyle/>
+          <a:p>
+            <a:pPr indent="0" marL="0">
+              <a:buNone/>
+            </a:pPr>
+            <a:r>
+              <a:rPr lang="en-US" sz="1200" b="1" dirty="0">
+                <a:solidFill>
+                  <a:srgbClr val="0F172A"/>
+                </a:solidFill>
+              </a:rPr>
+              <a:t>Explainability</a:t>
+            </a:r>
+            <a:endParaRPr lang="en-US" sz="1200" dirty="0"/>
+          </a:p>
+        </p:txBody>
+      </p:sp>
+      <p:sp>
+        <p:nvSpPr>
+          <p:cNvPr id="37" name="Text 35"/>
+          <p:cNvSpPr/>
+          <p:nvPr/>
+        </p:nvSpPr>
+        <p:spPr>
+          <a:xfrm>
+            <a:off x="914400" y="5458968"/>
+            <a:ext cx="2935224" cy="457200"/>
+          </a:xfrm>
+          <a:prstGeom prst="rect">
+            <a:avLst/>
+          </a:prstGeom>
+          <a:noFill/>
+          <a:ln/>
+        </p:spPr>
+        <p:txBody>
+          <a:bodyPr wrap="square" lIns="0" tIns="0" rIns="0" bIns="0" rtlCol="0" anchor="ctr">
+            <a:normAutofit/>
+          </a:bodyPr>
+          <a:lstStyle/>
+          <a:p>
+            <a:pPr indent="0" marL="0">
+              <a:buNone/>
+            </a:pPr>
+            <a:r>
+              <a:rPr lang="en-US" sz="950" dirty="0">
+                <a:solidFill>
+                  <a:srgbClr val="475569"/>
+                </a:solidFill>
+              </a:rPr>
+              <a:t>Reason, formula, audit timeline, and officer summary prompt contract.</a:t>
             </a:r>
             <a:endParaRPr lang="en-US" sz="950" dirty="0"/>
           </a:p>
@@ -10275,7 +10471,7 @@
                   <a:srgbClr val="475569"/>
                 </a:solidFill>
               </a:rPr>
-              <a:t>Synthetic Bengaluru smart meter readings, zone load, peer groups</a:t>
+              <a:t>Synthetic meter readings, Karnataka CSV load sample, zone load, peer groups</a:t>
             </a:r>
             <a:endParaRPr lang="en-US" sz="950" dirty="0"/>
           </a:p>
@@ -10591,7 +10787,7 @@
                   <a:srgbClr val="475569"/>
                 </a:solidFill>
               </a:rPr>
-              <a:t>React dashboard, Recharts analytics, officer workflow</a:t>
+              <a:t>React dashboard, tariff engine, scenario simulator, officer workflow</a:t>
             </a:r>
             <a:endParaRPr lang="en-US" sz="950" dirty="0"/>
           </a:p>
@@ -11528,7 +11724,7 @@
                   <a:srgbClr val="F97316"/>
                 </a:solidFill>
               </a:rPr>
-              <a:t>Gemini API / Google AI Studio ready</a:t>
+              <a:t>Vitest + GitHub Actions</a:t>
             </a:r>
             <a:endParaRPr lang="en-US" sz="1000" dirty="0"/>
           </a:p>
@@ -11591,7 +11787,7 @@
                   <a:srgbClr val="F97316"/>
                 </a:solidFill>
               </a:rPr>
-              <a:t>Firebase / Google Cloud ready</a:t>
+              <a:t>Gemini API / Google AI Studio ready</a:t>
             </a:r>
             <a:endParaRPr lang="en-US" sz="1000" dirty="0"/>
           </a:p>
@@ -11654,7 +11850,7 @@
                   <a:srgbClr val="F97316"/>
                 </a:solidFill>
               </a:rPr>
-              <a:t>Synthetic Bengaluru smart meter data</a:t>
+              <a:t>Firebase / Google Cloud ready</a:t>
             </a:r>
             <a:endParaRPr lang="en-US" sz="1000" dirty="0"/>
           </a:p>
@@ -11663,6 +11859,69 @@
       <p:sp>
         <p:nvSpPr>
           <p:cNvPr id="28" name="Shape 26"/>
+          <p:cNvSpPr/>
+          <p:nvPr/>
+        </p:nvSpPr>
+        <p:spPr>
+          <a:xfrm>
+            <a:off x="777240" y="3758184"/>
+            <a:ext cx="2971800" cy="384048"/>
+          </a:xfrm>
+          <a:prstGeom prst="roundRect">
+            <a:avLst>
+              <a:gd name="adj" fmla="val 19048"/>
+            </a:avLst>
+          </a:prstGeom>
+          <a:solidFill>
+            <a:srgbClr val="FFF7ED"/>
+          </a:solidFill>
+          <a:ln w="12700">
+            <a:solidFill>
+              <a:srgbClr val="FED7AA"/>
+            </a:solidFill>
+            <a:prstDash val="solid"/>
+          </a:ln>
+        </p:spPr>
+      </p:sp>
+      <p:sp>
+        <p:nvSpPr>
+          <p:cNvPr id="29" name="Text 27"/>
+          <p:cNvSpPr/>
+          <p:nvPr/>
+        </p:nvSpPr>
+        <p:spPr>
+          <a:xfrm>
+            <a:off x="923544" y="3849624"/>
+            <a:ext cx="2651760" cy="146304"/>
+          </a:xfrm>
+          <a:prstGeom prst="rect">
+            <a:avLst/>
+          </a:prstGeom>
+          <a:noFill/>
+          <a:ln/>
+        </p:spPr>
+        <p:txBody>
+          <a:bodyPr wrap="square" lIns="0" tIns="0" rIns="0" bIns="0" rtlCol="0" anchor="ctr"/>
+          <a:lstStyle/>
+          <a:p>
+            <a:pPr algn="ctr" indent="0" marL="0">
+              <a:buNone/>
+            </a:pPr>
+            <a:r>
+              <a:rPr lang="en-US" sz="1000" b="1" dirty="0">
+                <a:solidFill>
+                  <a:srgbClr val="F97316"/>
+                </a:solidFill>
+              </a:rPr>
+              <a:t>Synthetic Bengaluru smart meter data + Karnataka CSV sample</a:t>
+            </a:r>
+            <a:endParaRPr lang="en-US" sz="1000" dirty="0"/>
+          </a:p>
+        </p:txBody>
+      </p:sp>
+      <p:sp>
+        <p:nvSpPr>
+          <p:cNvPr id="30" name="Shape 28"/>
           <p:cNvSpPr/>
           <p:nvPr/>
         </p:nvSpPr>
@@ -11689,7 +11948,7 @@
       </p:sp>
       <p:sp>
         <p:nvSpPr>
-          <p:cNvPr id="29" name="Text 27"/>
+          <p:cNvPr id="31" name="Text 29"/>
           <p:cNvSpPr/>
           <p:nvPr/>
         </p:nvSpPr>
@@ -12283,7 +12542,7 @@
                   <a:srgbClr val="0F172A"/>
                 </a:solidFill>
               </a:rPr>
-              <a:t>Demand Forecast</a:t>
+              <a:t>Demand + Karnataka Data</a:t>
             </a:r>
             <a:endParaRPr lang="en-US" sz="1200" dirty="0"/>
           </a:p>
@@ -12321,7 +12580,7 @@
                   <a:srgbClr val="475569"/>
                 </a:solidFill>
               </a:rPr>
-              <a:t>Actual vs predicted load and peak warning</a:t>
+              <a:t>Actual vs predicted load plus localized feeder profile</a:t>
             </a:r>
             <a:endParaRPr lang="en-US" sz="950" dirty="0"/>
           </a:p>
@@ -12459,7 +12718,7 @@
                   <a:srgbClr val="0F172A"/>
                 </a:solidFill>
               </a:rPr>
-              <a:t>AI Alerts</a:t>
+              <a:t>AI Alerts + Summary</a:t>
             </a:r>
             <a:endParaRPr lang="en-US" sz="1200" dirty="0"/>
           </a:p>
@@ -12635,7 +12894,7 @@
                   <a:srgbClr val="0F172A"/>
                 </a:solidFill>
               </a:rPr>
-              <a:t>Revenue + Queue</a:t>
+              <a:t>Scenario Lab</a:t>
             </a:r>
             <a:endParaRPr lang="en-US" sz="1200" dirty="0"/>
           </a:p>
@@ -12673,7 +12932,7 @@
                   <a:srgbClr val="475569"/>
                 </a:solidFill>
               </a:rPr>
-              <a:t>Loss recovery chart and officer actions</a:t>
+              <a:t>Tariff savings, carbon impact, and officer actions</a:t>
             </a:r>
             <a:endParaRPr lang="en-US" sz="950" dirty="0"/>
           </a:p>

</xml_diff>

<commit_message>
Add SEO, sample data controls, and Vercel streaming path
</commit_message>
<xml_diff>
--- a/submission-deck/GridSense_AI_Prototype_Submission.pptx
+++ b/submission-deck/GridSense_AI_Prototype_Submission.pptx
@@ -8669,7 +8669,7 @@
                   <a:srgbClr val="0F172A"/>
                 </a:solidFill>
               </a:rPr>
-              <a:t>Inspection Queue</a:t>
+              <a:t>Sample Data Controls</a:t>
             </a:r>
             <a:endParaRPr lang="en-US" sz="1200" dirty="0"/>
           </a:p>
@@ -8707,7 +8707,7 @@
                   <a:srgbClr val="475569"/>
                 </a:solidFill>
               </a:rPr>
-              <a:t>Approve, reject, or escalate Bengaluru-area cases.</a:t>
+              <a:t>Load BESCOM sample, switch to India benchmark, or upload CSV for demo flexibility.</a:t>
             </a:r>
             <a:endParaRPr lang="en-US" sz="950" dirty="0"/>
           </a:p>
@@ -8802,6 +8802,139 @@
                   <a:srgbClr val="0F172A"/>
                 </a:solidFill>
               </a:rPr>
+              <a:t>Inspection Queue</a:t>
+            </a:r>
+            <a:endParaRPr lang="en-US" sz="1200" dirty="0"/>
+          </a:p>
+        </p:txBody>
+      </p:sp>
+      <p:sp>
+        <p:nvSpPr>
+          <p:cNvPr id="37" name="Text 35"/>
+          <p:cNvSpPr/>
+          <p:nvPr/>
+        </p:nvSpPr>
+        <p:spPr>
+          <a:xfrm>
+            <a:off x="914400" y="5458968"/>
+            <a:ext cx="2935224" cy="457200"/>
+          </a:xfrm>
+          <a:prstGeom prst="rect">
+            <a:avLst/>
+          </a:prstGeom>
+          <a:noFill/>
+          <a:ln/>
+        </p:spPr>
+        <p:txBody>
+          <a:bodyPr wrap="square" lIns="0" tIns="0" rIns="0" bIns="0" rtlCol="0" anchor="ctr">
+            <a:normAutofit/>
+          </a:bodyPr>
+          <a:lstStyle/>
+          <a:p>
+            <a:pPr indent="0" marL="0">
+              <a:buNone/>
+            </a:pPr>
+            <a:r>
+              <a:rPr lang="en-US" sz="950" dirty="0">
+                <a:solidFill>
+                  <a:srgbClr val="475569"/>
+                </a:solidFill>
+              </a:rPr>
+              <a:t>Approve, reject, or escalate Bengaluru-area cases.</a:t>
+            </a:r>
+            <a:endParaRPr lang="en-US" sz="950" dirty="0"/>
+          </a:p>
+        </p:txBody>
+      </p:sp>
+      <p:sp>
+        <p:nvSpPr>
+          <p:cNvPr id="38" name="Shape 36"/>
+          <p:cNvSpPr/>
+          <p:nvPr/>
+        </p:nvSpPr>
+        <p:spPr>
+          <a:xfrm>
+            <a:off x="4462272" y="4928616"/>
+            <a:ext cx="3337560" cy="1115568"/>
+          </a:xfrm>
+          <a:prstGeom prst="roundRect">
+            <a:avLst>
+              <a:gd name="adj" fmla="val 6557"/>
+            </a:avLst>
+          </a:prstGeom>
+          <a:solidFill>
+            <a:srgbClr val="FFFFFF"/>
+          </a:solidFill>
+          <a:ln w="12700">
+            <a:solidFill>
+              <a:srgbClr val="D9E2F2"/>
+            </a:solidFill>
+            <a:prstDash val="solid"/>
+          </a:ln>
+          <a:effectLst>
+            <a:outerShdw sx="100000" sy="100000" kx="0" ky="0" algn="bl" rotWithShape="0" blurRad="12700" dist="50800" dir="2700000">
+              <a:srgbClr val="DDE6F4">
+                <a:alpha val="35000"/>
+              </a:srgbClr>
+            </a:outerShdw>
+          </a:effectLst>
+        </p:spPr>
+      </p:sp>
+      <p:sp>
+        <p:nvSpPr>
+          <p:cNvPr id="39" name="Shape 37"/>
+          <p:cNvSpPr/>
+          <p:nvPr/>
+        </p:nvSpPr>
+        <p:spPr>
+          <a:xfrm>
+            <a:off x="4462272" y="4928616"/>
+            <a:ext cx="109728" cy="1115568"/>
+          </a:xfrm>
+          <a:prstGeom prst="rect">
+            <a:avLst/>
+          </a:prstGeom>
+          <a:solidFill>
+            <a:srgbClr val="2563EB"/>
+          </a:solidFill>
+          <a:ln w="12700">
+            <a:solidFill>
+              <a:srgbClr val="2563EB"/>
+            </a:solidFill>
+            <a:prstDash val="solid"/>
+          </a:ln>
+        </p:spPr>
+      </p:sp>
+      <p:sp>
+        <p:nvSpPr>
+          <p:cNvPr id="40" name="Text 38"/>
+          <p:cNvSpPr/>
+          <p:nvPr/>
+        </p:nvSpPr>
+        <p:spPr>
+          <a:xfrm>
+            <a:off x="4718304" y="5129784"/>
+            <a:ext cx="2935224" cy="219456"/>
+          </a:xfrm>
+          <a:prstGeom prst="rect">
+            <a:avLst/>
+          </a:prstGeom>
+          <a:noFill/>
+          <a:ln/>
+        </p:spPr>
+        <p:txBody>
+          <a:bodyPr wrap="square" lIns="0" tIns="0" rIns="0" bIns="0" rtlCol="0" anchor="ctr"/>
+          <a:lstStyle/>
+          <a:p>
+            <a:pPr indent="0" marL="0">
+              <a:buNone/>
+            </a:pPr>
+            <a:r>
+              <a:rPr lang="en-US" sz="1200" b="1" dirty="0">
+                <a:solidFill>
+                  <a:srgbClr val="0F172A"/>
+                </a:solidFill>
+              </a:rPr>
               <a:t>Explainability</a:t>
             </a:r>
             <a:endParaRPr lang="en-US" sz="1200" dirty="0"/>
@@ -8810,13 +8943,13 @@
       </p:sp>
       <p:sp>
         <p:nvSpPr>
-          <p:cNvPr id="37" name="Text 35"/>
-          <p:cNvSpPr/>
-          <p:nvPr/>
-        </p:nvSpPr>
-        <p:spPr>
-          <a:xfrm>
-            <a:off x="914400" y="5458968"/>
+          <p:cNvPr id="41" name="Text 39"/>
+          <p:cNvSpPr/>
+          <p:nvPr/>
+        </p:nvSpPr>
+        <p:spPr>
+          <a:xfrm>
+            <a:off x="4718304" y="5458968"/>
             <a:ext cx="2935224" cy="457200"/>
           </a:xfrm>
           <a:prstGeom prst="rect">
@@ -10629,7 +10762,7 @@
                   <a:srgbClr val="475569"/>
                 </a:solidFill>
               </a:rPr>
-              <a:t>Precomputed forecasting, anomaly scoring, Gemini-ready explanation summaries</a:t>
+              <a:t>Precomputed forecasting, anomaly scoring, Gemini-ready explanation summaries, Vercel SSE path</a:t>
             </a:r>
             <a:endParaRPr lang="en-US" sz="950" dirty="0"/>
           </a:p>
@@ -10945,7 +11078,7 @@
                   <a:srgbClr val="475569"/>
                 </a:solidFill>
               </a:rPr>
-              <a:t>Vercel static prototype now; Firebase/GCP-ready storage for pilot</a:t>
+              <a:t>Vercel static prototype now; SEO files, sitemap, robots, Firebase/GCP-ready pilot path</a:t>
             </a:r>
             <a:endParaRPr lang="en-US" sz="950" dirty="0"/>
           </a:p>
@@ -11787,7 +11920,7 @@
                   <a:srgbClr val="F97316"/>
                 </a:solidFill>
               </a:rPr>
-              <a:t>Gemini API / Google AI Studio ready</a:t>
+              <a:t>Vercel SSE endpoint</a:t>
             </a:r>
             <a:endParaRPr lang="en-US" sz="1000" dirty="0"/>
           </a:p>
@@ -11850,7 +11983,7 @@
                   <a:srgbClr val="F97316"/>
                 </a:solidFill>
               </a:rPr>
-              <a:t>Firebase / Google Cloud ready</a:t>
+              <a:t>Gemini API / Google AI Studio ready</a:t>
             </a:r>
             <a:endParaRPr lang="en-US" sz="1000" dirty="0"/>
           </a:p>
@@ -11913,6 +12046,69 @@
                   <a:srgbClr val="F97316"/>
                 </a:solidFill>
               </a:rPr>
+              <a:t>Firebase / Google Cloud ready</a:t>
+            </a:r>
+            <a:endParaRPr lang="en-US" sz="1000" dirty="0"/>
+          </a:p>
+        </p:txBody>
+      </p:sp>
+      <p:sp>
+        <p:nvSpPr>
+          <p:cNvPr id="30" name="Shape 28"/>
+          <p:cNvSpPr/>
+          <p:nvPr/>
+        </p:nvSpPr>
+        <p:spPr>
+          <a:xfrm>
+            <a:off x="4389120" y="3758184"/>
+            <a:ext cx="2971800" cy="384048"/>
+          </a:xfrm>
+          <a:prstGeom prst="roundRect">
+            <a:avLst>
+              <a:gd name="adj" fmla="val 19048"/>
+            </a:avLst>
+          </a:prstGeom>
+          <a:solidFill>
+            <a:srgbClr val="FFF7ED"/>
+          </a:solidFill>
+          <a:ln w="12700">
+            <a:solidFill>
+              <a:srgbClr val="FED7AA"/>
+            </a:solidFill>
+            <a:prstDash val="solid"/>
+          </a:ln>
+        </p:spPr>
+      </p:sp>
+      <p:sp>
+        <p:nvSpPr>
+          <p:cNvPr id="31" name="Text 29"/>
+          <p:cNvSpPr/>
+          <p:nvPr/>
+        </p:nvSpPr>
+        <p:spPr>
+          <a:xfrm>
+            <a:off x="4535424" y="3849624"/>
+            <a:ext cx="2651760" cy="146304"/>
+          </a:xfrm>
+          <a:prstGeom prst="rect">
+            <a:avLst/>
+          </a:prstGeom>
+          <a:noFill/>
+          <a:ln/>
+        </p:spPr>
+        <p:txBody>
+          <a:bodyPr wrap="square" lIns="0" tIns="0" rIns="0" bIns="0" rtlCol="0" anchor="ctr"/>
+          <a:lstStyle/>
+          <a:p>
+            <a:pPr algn="ctr" indent="0" marL="0">
+              <a:buNone/>
+            </a:pPr>
+            <a:r>
+              <a:rPr lang="en-US" sz="1000" b="1" dirty="0">
+                <a:solidFill>
+                  <a:srgbClr val="F97316"/>
+                </a:solidFill>
+              </a:rPr>
               <a:t>Synthetic Bengaluru smart meter data + Karnataka CSV sample</a:t>
             </a:r>
             <a:endParaRPr lang="en-US" sz="1000" dirty="0"/>
@@ -11921,7 +12117,7 @@
       </p:sp>
       <p:sp>
         <p:nvSpPr>
-          <p:cNvPr id="30" name="Shape 28"/>
+          <p:cNvPr id="32" name="Shape 30"/>
           <p:cNvSpPr/>
           <p:nvPr/>
         </p:nvSpPr>
@@ -11948,7 +12144,7 @@
       </p:sp>
       <p:sp>
         <p:nvSpPr>
-          <p:cNvPr id="31" name="Text 29"/>
+          <p:cNvPr id="33" name="Text 31"/>
           <p:cNvSpPr/>
           <p:nvPr/>
         </p:nvSpPr>

</xml_diff>